<commit_message>
fix: auditoria de consistência — atualiza todos os valores numéricos
Valores corrigidos em todos os documentos (Word, PPT, guia, LaTeX):

HLM M4 gap residual: 5,4% → 6,2% (exp(-0.0644)-1 = -6.24%)
HLM M1 gap bruto: 19,5% → 19,3% (exp(-0.2148)-1 = -19.33%)
HLM M3 gap líquido: 9,5% → 9,7%
Mediação UPA: 10,5pp/54% → 9,6pp/52%
Mediação ocupacional: 4,1pp → 3,5pp
Mediação total: 74,5% → 70,0%
OR GLMM M1: 0,705 → 0,704

Konfound — população completa (N=7.689.426):
  pkonfound HLM: 98,8%(M1)/97,5%(M2M3)/96,3%(M4) → 99,5%/98,8%/98,5%
  t HLM: -165,3(M1)/-53,1(M4) → -358,0/-128,8
  pkonfound OLS: 91,4%/92,5%/86,8% → 91,5%/93,5%/88,7%
  Δ pkonfound: 5,0–9,5pp → 5,4–9,7pp
  SE ratio OLS/HLM: 3,5–7× → 6–16×

CSVs atualizados: konfound_hlm.csv, konfound_hlm_vs_ols.csv,
  konfound_hlm_vs_ols.tex, sensibilidade_comparativa.csv

Co-Authored-By: Claude Sonnet 4.6 <noreply@anthropic.com>
</commit_message>
<xml_diff>
--- a/apresentacao_executiva.pptx
+++ b/apresentacao_executiva.pptx
@@ -4577,7 +4577,7 @@
                 </a:solidFill>
                 <a:latin typeface="Calibri"/>
               </a:rPr>
-              <a:t>O gap residual de 5,4% é real
+              <a:t>O gap residual de 6,2% é real
 e mensurável — e deve ser eliminado</a:t>
             </a:r>
           </a:p>
@@ -7377,7 +7377,7 @@
                 </a:solidFill>
                 <a:latin typeface="Calibri"/>
               </a:rPr>
-              <a:t>Após controlar todas as características observáveis, negros ainda recebem 5,4% menos na mesma função. No topo salarial esse gap chega a 12%.</a:t>
+              <a:t>Após controlar todas as características observáveis, negros ainda recebem 6,2% menos na mesma função. No topo salarial esse gap chega a 12%.</a:t>
             </a:r>
           </a:p>
         </p:txBody>

</xml_diff>

<commit_message>
feat: item 4 (GLMM genero) nas apresentacoes
- Deck tecnico (apresentacao_tcc): novo slide 25 "Random Slope GLMM de Genero —
  Teto de Remuneracao, nao de Categoria" (figura glmm_genero_real.png),
  renumeracao para total=28.
- Deck executivo (apresentacao_executiva_tcc): nota de genero no slide de glass
  ceiling (mulheres acessam ocupacoes qualificadas OR=2,01 mas nao o topo de
  renda OR top10=0,52).
- Deck leigo (apresentacao_executiva): teto de vidro de genero adicionado ao
  callout do slide "O Teto de Vidro E Real".

Co-Authored-By: Claude Opus 4.8 <noreply@anthropic.com>
</commit_message>
<xml_diff>
--- a/apresentacao_executiva.pptx
+++ b/apresentacao_executiva.pptx
@@ -11586,7 +11586,7 @@
         <p:spPr>
           <a:xfrm>
             <a:off x="274320" y="5596128"/>
-            <a:ext cx="11612880" cy="566928"/>
+            <a:ext cx="11612880" cy="713232"/>
           </a:xfrm>
           <a:prstGeom prst="rect">
             <a:avLst/>
@@ -11631,7 +11631,7 @@
         <p:spPr>
           <a:xfrm>
             <a:off x="411480" y="5687568"/>
-            <a:ext cx="11338560" cy="384048"/>
+            <a:ext cx="11338560" cy="530352"/>
           </a:xfrm>
           <a:prstGeom prst="rect">
             <a:avLst/>
@@ -11652,7 +11652,7 @@
                 </a:solidFill>
                 <a:latin typeface="Calibri"/>
               </a:rPr>
-              <a:t>Ciclo de vida: o gap cresce de 9% (14–24 anos) para 37,5% (35–44 anos, pico de carreira) — o teto de vidro se fecha exatamente quando as promoções mais importam.</a:t>
+              <a:t>Ciclo de vida (raça): o gap cresce de 9% para 37,5% no pico da carreira. E há um teto de vidro de GÊNERO distinto: mulheres chegam às profissões qualificadas, mas não ao topo dos salários.</a:t>
             </a:r>
           </a:p>
         </p:txBody>

</xml_diff>

<commit_message>
fix: sincroniza valores setoriais (H2/H3) com a figura atual nos decks/guia/Word
Os gaps por setor estavam desatualizados e inconsistentes entre arquivos.
Sincronizados com a figura atual estado_h2h3_gaps.png (fonte autoritativa):
- Racial controlado: publico -28,3% | privado -34,5% (era -24,6/-25,2 vs -29,2)
- Racial bruto: publico -32,4% | privado -44,1%
- Genero controlado: publico -20,9% | privado -18,6% (era -18,8/-20,8 vs -16,9)
- Diferencas recalculadas: racial 6,2 pp; genero 2,3 pp.
Aplicado em apresentacao_executiva (leigo), apresentacao_tcc (tecnico),
guia_estudo_defesa e relatorio (Word). Decks/docs regenerados.

Co-Authored-By: Claude Opus 4.8 <noreply@anthropic.com>
</commit_message>
<xml_diff>
--- a/apresentacao_executiva.pptx
+++ b/apresentacao_executiva.pptx
@@ -13019,7 +13019,7 @@
                 </a:solidFill>
                 <a:latin typeface="Calibri"/>
               </a:rPr>
-              <a:t>−25,2% público vs −29,2% privado</a:t>
+              <a:t>−28,3% público vs −34,5% privado</a:t>
             </a:r>
           </a:p>
         </p:txBody>
@@ -13169,7 +13169,7 @@
                 </a:solidFill>
                 <a:latin typeface="Calibri"/>
               </a:rPr>
-              <a:t>−20,8% público vs −16,9% privado</a:t>
+              <a:t>−20,9% público vs −18,6% privado</a:t>
             </a:r>
           </a:p>
         </p:txBody>

</xml_diff>

<commit_message>
fix: lay deck — adiciona nota de contexto IBGE (faltava; perícia)
A perícia detectou que o deck executivo lay tinha o slide de interseccionalidade
mas estava sem a nota de contexto IBGE (presente no deck técnico e no exec-pptx).
Adicionada na slide do Estado/Gini (qualidade de vida ↑ via POF, mas Gini de renda
↑ a 0,491 em 2025 — o avanço nao fecha o gap racial).
</commit_message>
<xml_diff>
--- a/apresentacao_executiva.pptx
+++ b/apresentacao_executiva.pptx
@@ -14700,8 +14700,8 @@
         </p:nvSpPr>
         <p:spPr>
           <a:xfrm>
-            <a:off x="274320" y="5833872"/>
-            <a:ext cx="11612880" cy="502920"/>
+            <a:off x="274320" y="5788152"/>
+            <a:ext cx="11612880" cy="457200"/>
           </a:xfrm>
           <a:prstGeom prst="rect">
             <a:avLst/>
@@ -14745,8 +14745,8 @@
         </p:nvSpPr>
         <p:spPr>
           <a:xfrm>
-            <a:off x="411480" y="5925312"/>
-            <a:ext cx="11338560" cy="320040"/>
+            <a:off x="411480" y="5879592"/>
+            <a:ext cx="11338560" cy="274320"/>
           </a:xfrm>
           <a:prstGeom prst="rect">
             <a:avLst/>
@@ -14774,7 +14774,42 @@
       </p:sp>
       <p:sp>
         <p:nvSpPr>
-          <p:cNvPr id="21" name="Rectangle 20"/>
+          <p:cNvPr id="21" name="TextBox 20"/>
+          <p:cNvSpPr txBox="1"/>
+          <p:nvPr/>
+        </p:nvSpPr>
+        <p:spPr>
+          <a:xfrm>
+            <a:off x="320040" y="6327648"/>
+            <a:ext cx="11521440" cy="256032"/>
+          </a:xfrm>
+          <a:prstGeom prst="rect">
+            <a:avLst/>
+          </a:prstGeom>
+          <a:noFill/>
+        </p:spPr>
+        <p:txBody>
+          <a:bodyPr wrap="square">
+            <a:spAutoFit/>
+          </a:bodyPr>
+          <a:lstStyle/>
+          <a:p>
+            <a:pPr algn="l"/>
+            <a:r>
+              <a:rPr sz="950" b="0" i="1">
+                <a:solidFill>
+                  <a:srgbClr val="616161"/>
+                </a:solidFill>
+                <a:latin typeface="Calibri"/>
+              </a:rPr>
+              <a:t>Contexto IBGE 2025: a qualidade de vida melhorou (POF), mas a desigualdade de renda voltou a subir (Gini per capita 0,491) — o avanço agregado não fecha o gap racial.</a:t>
+            </a:r>
+          </a:p>
+        </p:txBody>
+      </p:sp>
+      <p:sp>
+        <p:nvSpPr>
+          <p:cNvPr id="22" name="Rectangle 21"/>
           <p:cNvSpPr/>
           <p:nvPr/>
         </p:nvSpPr>
@@ -14815,7 +14850,7 @@
       </p:sp>
       <p:sp>
         <p:nvSpPr>
-          <p:cNvPr id="22" name="TextBox 21"/>
+          <p:cNvPr id="23" name="TextBox 22"/>
           <p:cNvSpPr txBox="1"/>
           <p:nvPr/>
         </p:nvSpPr>
@@ -14850,7 +14885,7 @@
       </p:sp>
       <p:sp>
         <p:nvSpPr>
-          <p:cNvPr id="23" name="TextBox 22"/>
+          <p:cNvPr id="24" name="TextBox 23"/>
           <p:cNvSpPr txBox="1"/>
           <p:nvPr/>
         </p:nvSpPr>

</xml_diff>